<commit_message>
docs: surface the opt-out plan-approval gate on the deck safety slide
Co-Authored-By: Claude Opus 4.8 (1M context) <noreply@anthropic.com>
</commit_message>
<xml_diff>
--- a/docs/decks/web-modernize-presentation.pptx
+++ b/docs/decks/web-modernize-presentation.pptx
@@ -17609,7 +17609,7 @@
                 </a:solidFill>
                 <a:latin typeface="Calibri"/>
               </a:rPr>
-              <a:t>Nothing is one-way</a:t>
+              <a:t>Approved going in, reversible coming out</a:t>
             </a:r>
           </a:p>
         </p:txBody>
@@ -17644,7 +17644,7 @@
                 </a:solidFill>
                 <a:latin typeface="Calibri"/>
               </a:rPr>
-              <a:t>Every action is recorded in git — the team can see who did what, when, with what input. One command  (/rollback --unit &lt;id&gt;)  reverts a single unit cleanly. Destructive commands  (/abandon --hard)  require a two-step confirmation; no accidental wipes. Per-unit notes capture the why alongside the what.</a:t>
+              <a:t>Nothing risky is written blind: by default /next presents each unit's plan — target files, approach, tests — and waits for your approval before writing a line (opt out per migration via review_mode, or per unit via --no-plan); /foundation always gates the auth + cross-cutting design. And nothing is one-way: every action is recorded in git, one command  (/rollback --unit &lt;id&gt;)  reverts a unit cleanly (refusing shared files unless forced), and destructive commands  (/abandon --hard)  need a two-step confirm. Per-unit notes capture the why alongside the what.</a:t>
             </a:r>
           </a:p>
         </p:txBody>

</xml_diff>

<commit_message>
docs: finish v0.18.0 docs-sync (SVG + decks) and prune shipped todos
- architecture-p2-plugin.svg: add the 19th skill box (next-batch), complete the
  workflow-scripts list to 4 (next-batch, verify-run), fix agents 6 -> 5
- build_presentation.py + regenerated decks: add the next-batch command row and
  the two missing workflow-script rows
- docs/planning/todo.md: rewrite to a pending-only backlog (drop shipped items,
  fold in dry-run follow-ups + deferred review items)

Maintainer docs/housekeeping only; nothing the plugin loads at runtime changed,
so no version bump.

Co-Authored-By: Claude Opus 4.8 (1M context) <noreply@anthropic.com>
</commit_message>
<xml_diff>
--- a/docs/decks/web-modernize-presentation.pptx
+++ b/docs/decks/web-modernize-presentation.pptx
@@ -3455,7 +3455,7 @@
                 </a:solidFill>
                 <a:latin typeface="Segoe UI Semibold"/>
               </a:rPr>
-              <a:t>Balaji Harikrishnan   ·   Cognizant   ·   July 2026   ·   v0.16.0</a:t>
+              <a:t>Balaji Harikrishnan   ·   Cognizant   ·   July 2026   ·   v0.18.0</a:t>
             </a:r>
           </a:p>
         </p:txBody>
@@ -3754,7 +3754,7 @@
                 </a:solidFill>
                 <a:latin typeface="Calibri"/>
               </a:rPr>
-              <a:t>web-modernize v0.16.0   ·   Balaji Harikrishnan   ·   Cognizant   ·   July 2026</a:t>
+              <a:t>web-modernize v0.18.0   ·   Balaji Harikrishnan   ·   Cognizant   ·   July 2026</a:t>
             </a:r>
           </a:p>
         </p:txBody>
@@ -5899,7 +5899,7 @@
                 </a:solidFill>
                 <a:latin typeface="Segoe UI Semibold"/>
               </a:rPr>
-              <a:t>The 18 Skills  (Slash Commands)</a:t>
+              <a:t>The 19 Skills  (Slash Commands)</a:t>
             </a:r>
           </a:p>
         </p:txBody>
@@ -6013,7 +6013,7 @@
                 </a:solidFill>
                 <a:latin typeface="Calibri"/>
               </a:rPr>
-              <a:t>web-modernize v0.16.0   ·   Balaji Harikrishnan   ·   Cognizant   ·   July 2026</a:t>
+              <a:t>web-modernize v0.18.0   ·   Balaji Harikrishnan   ·   Cognizant   ·   July 2026</a:t>
             </a:r>
           </a:p>
         </p:txBody>
@@ -6063,7 +6063,7 @@
         </p:nvGraphicFramePr>
         <p:xfrm>
           <a:off x="365760" y="1152144"/>
-          <a:ext cx="11460174" cy="5298948"/>
+          <a:ext cx="11460174" cy="5303520"/>
         </p:xfrm>
         <a:graphic>
           <a:graphicData uri="http://schemas.openxmlformats.org/drawingml/2006/table">
@@ -6075,7 +6075,7 @@
                 <a:gridCol w="2062831"/>
                 <a:gridCol w="9397343"/>
               </a:tblGrid>
-              <a:tr h="278892">
+              <a:tr h="265176">
                 <a:tc>
                   <a:txBody>
                     <a:bodyPr/>
@@ -6123,7 +6123,7 @@
                   </a:tcPr>
                 </a:tc>
               </a:tr>
-              <a:tr h="278892">
+              <a:tr h="265176">
                 <a:tc>
                   <a:txBody>
                     <a:bodyPr/>
@@ -6171,7 +6171,7 @@
                   </a:tcPr>
                 </a:tc>
               </a:tr>
-              <a:tr h="278892">
+              <a:tr h="265176">
                 <a:tc>
                   <a:txBody>
                     <a:bodyPr/>
@@ -6219,7 +6219,7 @@
                   </a:tcPr>
                 </a:tc>
               </a:tr>
-              <a:tr h="278892">
+              <a:tr h="265176">
                 <a:tc>
                   <a:txBody>
                     <a:bodyPr/>
@@ -6267,7 +6267,7 @@
                   </a:tcPr>
                 </a:tc>
               </a:tr>
-              <a:tr h="278892">
+              <a:tr h="265176">
                 <a:tc>
                   <a:txBody>
                     <a:bodyPr/>
@@ -6315,7 +6315,7 @@
                   </a:tcPr>
                 </a:tc>
               </a:tr>
-              <a:tr h="278892">
+              <a:tr h="265176">
                 <a:tc>
                   <a:txBody>
                     <a:bodyPr/>
@@ -6363,7 +6363,7 @@
                   </a:tcPr>
                 </a:tc>
               </a:tr>
-              <a:tr h="278892">
+              <a:tr h="265176">
                 <a:tc>
                   <a:txBody>
                     <a:bodyPr/>
@@ -6411,7 +6411,7 @@
                   </a:tcPr>
                 </a:tc>
               </a:tr>
-              <a:tr h="278892">
+              <a:tr h="265176">
                 <a:tc>
                   <a:txBody>
                     <a:bodyPr/>
@@ -6425,7 +6425,7 @@
                           </a:solidFill>
                           <a:latin typeface="Consolas"/>
                         </a:rPr>
-                        <a:t>/migrate</a:t>
+                        <a:t>/next-batch</a:t>
                       </a:r>
                     </a:p>
                   </a:txBody>
@@ -6448,7 +6448,7 @@
                           </a:solidFill>
                           <a:latin typeface="Calibri"/>
                         </a:rPr>
-                        <a:t>Migrates a specific unit by name — used when standup assigns work.</a:t>
+                        <a:t>Migrates several independent units in parallel in one pass — faster throughput than /next, but always skips the per-unit plan gate.</a:t>
                       </a:r>
                     </a:p>
                   </a:txBody>
@@ -6459,7 +6459,7 @@
                   </a:tcPr>
                 </a:tc>
               </a:tr>
-              <a:tr h="278892">
+              <a:tr h="265176">
                 <a:tc>
                   <a:txBody>
                     <a:bodyPr/>
@@ -6473,7 +6473,7 @@
                           </a:solidFill>
                           <a:latin typeface="Consolas"/>
                         </a:rPr>
-                        <a:t>/verify</a:t>
+                        <a:t>/migrate</a:t>
                       </a:r>
                     </a:p>
                   </a:txBody>
@@ -6496,7 +6496,7 @@
                           </a:solidFill>
                           <a:latin typeface="Calibri"/>
                         </a:rPr>
-                        <a:t>Runs lint, type-check, tests, a behavioural-parity + security gate, and advisory code-quality + static-performance review; an opt-in dynamic tier (API replay + Playwright E2E) adds runtime checks.</a:t>
+                        <a:t>Migrates a specific unit by name — used when standup assigns work.</a:t>
                       </a:r>
                     </a:p>
                   </a:txBody>
@@ -6507,7 +6507,7 @@
                   </a:tcPr>
                 </a:tc>
               </a:tr>
-              <a:tr h="278892">
+              <a:tr h="265176">
                 <a:tc>
                   <a:txBody>
                     <a:bodyPr/>
@@ -6521,7 +6521,7 @@
                           </a:solidFill>
                           <a:latin typeface="Consolas"/>
                         </a:rPr>
-                        <a:t>/parity-check</a:t>
+                        <a:t>/verify</a:t>
                       </a:r>
                     </a:p>
                   </a:txBody>
@@ -6544,7 +6544,7 @@
                           </a:solidFill>
                           <a:latin typeface="Calibri"/>
                         </a:rPr>
-                        <a:t>Compares a migrated unit's behaviour against the legacy original — validation, output shape, errors, UI states, security — and lets the team acknowledge intentional differences.</a:t>
+                        <a:t>Runs lint, type-check, tests, a behavioural-parity + security gate, and advisory code-quality + static-performance review; an opt-in dynamic tier (API replay + Playwright E2E) adds runtime checks.</a:t>
                       </a:r>
                     </a:p>
                   </a:txBody>
@@ -6555,7 +6555,7 @@
                   </a:tcPr>
                 </a:tc>
               </a:tr>
-              <a:tr h="278892">
+              <a:tr h="265176">
                 <a:tc>
                   <a:txBody>
                     <a:bodyPr/>
@@ -6569,7 +6569,7 @@
                           </a:solidFill>
                           <a:latin typeface="Consolas"/>
                         </a:rPr>
-                        <a:t>/quality-check</a:t>
+                        <a:t>/parity-check</a:t>
                       </a:r>
                     </a:p>
                   </a:txBody>
@@ -6592,7 +6592,7 @@
                           </a:solidFill>
                           <a:latin typeface="Calibri"/>
                         </a:rPr>
-                        <a:t>Advisory review of the migrated code's idiomaticity and static performance — flags legacy patterns and N+1/bundle/blocking regressions. Never blocks.</a:t>
+                        <a:t>Compares a migrated unit's behaviour against the legacy original — validation, output shape, errors, UI states, security — and lets the team acknowledge intentional differences.</a:t>
                       </a:r>
                     </a:p>
                   </a:txBody>
@@ -6603,7 +6603,7 @@
                   </a:tcPr>
                 </a:tc>
               </a:tr>
-              <a:tr h="278892">
+              <a:tr h="265176">
                 <a:tc>
                   <a:txBody>
                     <a:bodyPr/>
@@ -6617,7 +6617,7 @@
                           </a:solidFill>
                           <a:latin typeface="Consolas"/>
                         </a:rPr>
-                        <a:t>/integrate</a:t>
+                        <a:t>/quality-check</a:t>
                       </a:r>
                     </a:p>
                   </a:txBody>
@@ -6640,7 +6640,7 @@
                           </a:solidFill>
                           <a:latin typeface="Calibri"/>
                         </a:rPr>
-                        <a:t>Assembles the migrated units into the composed app — central router + nav, whole-app smoke, orphaned-unit + cutover-coverage report, and the strangler traffic-split proxy. Runs any time; idempotent.</a:t>
+                        <a:t>Advisory review of the migrated code's idiomaticity and static performance — flags legacy patterns and N+1/bundle/blocking regressions. Never blocks.</a:t>
                       </a:r>
                     </a:p>
                   </a:txBody>
@@ -6651,7 +6651,7 @@
                   </a:tcPr>
                 </a:tc>
               </a:tr>
-              <a:tr h="278892">
+              <a:tr h="265176">
                 <a:tc>
                   <a:txBody>
                     <a:bodyPr/>
@@ -6665,7 +6665,7 @@
                           </a:solidFill>
                           <a:latin typeface="Consolas"/>
                         </a:rPr>
-                        <a:t>/retry</a:t>
+                        <a:t>/integrate</a:t>
                       </a:r>
                     </a:p>
                   </a:txBody>
@@ -6688,7 +6688,7 @@
                           </a:solidFill>
                           <a:latin typeface="Calibri"/>
                         </a:rPr>
-                        <a:t>Re-attempts a failed unit, optionally with team-supplied corrective guidance.</a:t>
+                        <a:t>Assembles the migrated units into the composed app — central router + nav, whole-app smoke, orphaned-unit + cutover-coverage report, and the strangler traffic-split proxy. Runs any time; idempotent.</a:t>
                       </a:r>
                     </a:p>
                   </a:txBody>
@@ -6699,7 +6699,7 @@
                   </a:tcPr>
                 </a:tc>
               </a:tr>
-              <a:tr h="278892">
+              <a:tr h="265176">
                 <a:tc>
                   <a:txBody>
                     <a:bodyPr/>
@@ -6713,7 +6713,7 @@
                           </a:solidFill>
                           <a:latin typeface="Consolas"/>
                         </a:rPr>
-                        <a:t>/rollback</a:t>
+                        <a:t>/retry</a:t>
                       </a:r>
                     </a:p>
                   </a:txBody>
@@ -6736,7 +6736,7 @@
                           </a:solidFill>
                           <a:latin typeface="Calibri"/>
                         </a:rPr>
-                        <a:t>Reverts a single unit back to its original state in one git command — refusing by default when it owns shared files others depend on.</a:t>
+                        <a:t>Re-attempts a failed unit, optionally with team-supplied corrective guidance.</a:t>
                       </a:r>
                     </a:p>
                   </a:txBody>
@@ -6747,7 +6747,7 @@
                   </a:tcPr>
                 </a:tc>
               </a:tr>
-              <a:tr h="278892">
+              <a:tr h="265176">
                 <a:tc>
                   <a:txBody>
                     <a:bodyPr/>
@@ -6761,7 +6761,7 @@
                           </a:solidFill>
                           <a:latin typeface="Consolas"/>
                         </a:rPr>
-                        <a:t>/sync</a:t>
+                        <a:t>/rollback</a:t>
                       </a:r>
                     </a:p>
                   </a:txBody>
@@ -6784,7 +6784,7 @@
                           </a:solidFill>
                           <a:latin typeface="Calibri"/>
                         </a:rPr>
-                        <a:t>Merges teammates' parallel progress into the local copy with deterministic rules.</a:t>
+                        <a:t>Reverts a single unit back to its original state in one git command — refusing by default when it owns shared files others depend on.</a:t>
                       </a:r>
                     </a:p>
                   </a:txBody>
@@ -6795,7 +6795,7 @@
                   </a:tcPr>
                 </a:tc>
               </a:tr>
-              <a:tr h="278892">
+              <a:tr h="265176">
                 <a:tc>
                   <a:txBody>
                     <a:bodyPr/>
@@ -6809,7 +6809,7 @@
                           </a:solidFill>
                           <a:latin typeface="Consolas"/>
                         </a:rPr>
-                        <a:t>/report</a:t>
+                        <a:t>/sync</a:t>
                       </a:r>
                     </a:p>
                   </a:txBody>
@@ -6832,7 +6832,7 @@
                           </a:solidFill>
                           <a:latin typeface="Calibri"/>
                         </a:rPr>
-                        <a:t>Generates a stakeholder report — burndown, ETA, risk — in Markdown, JSON, or HTML.</a:t>
+                        <a:t>Merges teammates' parallel progress into the local copy with deterministic rules.</a:t>
                       </a:r>
                     </a:p>
                   </a:txBody>
@@ -6843,7 +6843,7 @@
                   </a:tcPr>
                 </a:tc>
               </a:tr>
-              <a:tr h="278892">
+              <a:tr h="265176">
                 <a:tc>
                   <a:txBody>
                     <a:bodyPr/>
@@ -6857,7 +6857,7 @@
                           </a:solidFill>
                           <a:latin typeface="Consolas"/>
                         </a:rPr>
-                        <a:t>/status</a:t>
+                        <a:t>/report</a:t>
                       </a:r>
                     </a:p>
                   </a:txBody>
@@ -6880,7 +6880,7 @@
                           </a:solidFill>
                           <a:latin typeface="Calibri"/>
                         </a:rPr>
-                        <a:t>Shows a real-time dashboard of every unit, owner, and blocker (read-only).</a:t>
+                        <a:t>Generates a stakeholder report — burndown, ETA, risk — in Markdown, JSON, or HTML.</a:t>
                       </a:r>
                     </a:p>
                   </a:txBody>
@@ -6891,7 +6891,7 @@
                   </a:tcPr>
                 </a:tc>
               </a:tr>
-              <a:tr h="278892">
+              <a:tr h="265176">
                 <a:tc>
                   <a:txBody>
                     <a:bodyPr/>
@@ -6905,7 +6905,7 @@
                           </a:solidFill>
                           <a:latin typeface="Consolas"/>
                         </a:rPr>
-                        <a:t>/unlock</a:t>
+                        <a:t>/status</a:t>
                       </a:r>
                     </a:p>
                   </a:txBody>
@@ -6928,7 +6928,7 @@
                           </a:solidFill>
                           <a:latin typeface="Calibri"/>
                         </a:rPr>
-                        <a:t>Force-clears a stuck advisory lock left behind by a crashed session.</a:t>
+                        <a:t>Shows a real-time dashboard of every unit, owner, and blocker (read-only).</a:t>
                       </a:r>
                     </a:p>
                   </a:txBody>
@@ -6939,7 +6939,7 @@
                   </a:tcPr>
                 </a:tc>
               </a:tr>
-              <a:tr h="278892">
+              <a:tr h="265176">
                 <a:tc>
                   <a:txBody>
                     <a:bodyPr/>
@@ -6953,7 +6953,7 @@
                           </a:solidFill>
                           <a:latin typeface="Consolas"/>
                         </a:rPr>
-                        <a:t>/abandon</a:t>
+                        <a:t>/unlock</a:t>
                       </a:r>
                     </a:p>
                   </a:txBody>
@@ -6976,13 +6976,61 @@
                           </a:solidFill>
                           <a:latin typeface="Calibri"/>
                         </a:rPr>
+                        <a:t>Force-clears a stuck advisory lock left behind by a crashed session.</a:t>
+                      </a:r>
+                    </a:p>
+                  </a:txBody>
+                  <a:tcPr anchor="ctr" marL="73152" marR="73152" marT="18288" marB="18288">
+                    <a:solidFill>
+                      <a:srgbClr val="EBF2FF"/>
+                    </a:solidFill>
+                  </a:tcPr>
+                </a:tc>
+              </a:tr>
+              <a:tr h="265176">
+                <a:tc>
+                  <a:txBody>
+                    <a:bodyPr/>
+                    <a:lstStyle/>
+                    <a:p>
+                      <a:pPr algn="l"/>
+                      <a:r>
+                        <a:rPr sz="1000" b="1" i="0">
+                          <a:solidFill>
+                            <a:srgbClr val="1A56DB"/>
+                          </a:solidFill>
+                          <a:latin typeface="Consolas"/>
+                        </a:rPr>
+                        <a:t>/abandon</a:t>
+                      </a:r>
+                    </a:p>
+                  </a:txBody>
+                  <a:tcPr anchor="ctr" marL="73152" marR="73152" marT="18288" marB="18288">
+                    <a:solidFill>
+                      <a:srgbClr val="FAFBFC"/>
+                    </a:solidFill>
+                  </a:tcPr>
+                </a:tc>
+                <a:tc>
+                  <a:txBody>
+                    <a:bodyPr/>
+                    <a:lstStyle/>
+                    <a:p>
+                      <a:pPr algn="l"/>
+                      <a:r>
+                        <a:rPr sz="1000" b="0" i="0">
+                          <a:solidFill>
+                            <a:srgbClr val="1F2937"/>
+                          </a:solidFill>
+                          <a:latin typeface="Calibri"/>
+                        </a:rPr>
                         <a:t>Formally drops a unit or resets the workspace — requires two-step confirmation.</a:t>
                       </a:r>
                     </a:p>
                   </a:txBody>
                   <a:tcPr anchor="ctr" marL="73152" marR="73152" marT="18288" marB="18288">
                     <a:solidFill>
-                      <a:srgbClr val="EBF2FF"/>
+                      <a:srgbClr val="FAFBFC"/>
                     </a:solidFill>
                   </a:tcPr>
                 </a:tc>
@@ -7285,7 +7333,7 @@
                 </a:solidFill>
                 <a:latin typeface="Calibri"/>
               </a:rPr>
-              <a:t>web-modernize v0.16.0   ·   Balaji Harikrishnan   ·   Cognizant   ·   July 2026</a:t>
+              <a:t>web-modernize v0.18.0   ·   Balaji Harikrishnan   ·   Cognizant   ·   July 2026</a:t>
             </a:r>
           </a:p>
         </p:txBody>
@@ -7355,7 +7403,7 @@
                 </a:solidFill>
                 <a:latin typeface="Segoe UI Semibold"/>
               </a:rPr>
-              <a:t>6 AI Agents   (specialised AIs that read your code, translate it, verify behaviour, quality &amp; performance, and steer around known pitfalls)</a:t>
+              <a:t>5 AI Agents   (specialised AIs that read your code, translate it, verify behaviour, quality &amp; performance, and steer around known pitfalls)</a:t>
             </a:r>
           </a:p>
         </p:txBody>
@@ -7370,7 +7418,7 @@
         </p:nvGraphicFramePr>
         <p:xfrm>
           <a:off x="365760" y="1371600"/>
-          <a:ext cx="11460174" cy="1376172"/>
+          <a:ext cx="11460174" cy="1179576"/>
         </p:xfrm>
         <a:graphic>
           <a:graphicData uri="http://schemas.openxmlformats.org/drawingml/2006/table">
@@ -7670,54 +7718,6 @@
                   </a:tcPr>
                 </a:tc>
               </a:tr>
-              <a:tr h="196596">
-                <a:tc>
-                  <a:txBody>
-                    <a:bodyPr/>
-                    <a:lstStyle/>
-                    <a:p>
-                      <a:pPr algn="l"/>
-                      <a:r>
-                        <a:rPr sz="1000" b="1" i="0">
-                          <a:solidFill>
-                            <a:srgbClr val="1A56DB"/>
-                          </a:solidFill>
-                          <a:latin typeface="Consolas"/>
-                        </a:rPr>
-                        <a:t>permanent-gotchas</a:t>
-                      </a:r>
-                    </a:p>
-                  </a:txBody>
-                  <a:tcPr anchor="ctr" marL="73152" marR="73152" marT="18288" marB="18288">
-                    <a:solidFill>
-                      <a:srgbClr val="EBF2FF"/>
-                    </a:solidFill>
-                  </a:tcPr>
-                </a:tc>
-                <a:tc>
-                  <a:txBody>
-                    <a:bodyPr/>
-                    <a:lstStyle/>
-                    <a:p>
-                      <a:pPr algn="l"/>
-                      <a:r>
-                        <a:rPr sz="1000" b="0" i="0">
-                          <a:solidFill>
-                            <a:srgbClr val="1F2937"/>
-                          </a:solidFill>
-                          <a:latin typeface="Calibri"/>
-                        </a:rPr>
-                        <a:t>Curated read-only catalog of bugs the AI cannot reliably discover on its own — first-run crashes and silent failures.</a:t>
-                      </a:r>
-                    </a:p>
-                  </a:txBody>
-                  <a:tcPr anchor="ctr" marL="73152" marR="73152" marT="18288" marB="18288">
-                    <a:solidFill>
-                      <a:srgbClr val="EBF2FF"/>
-                    </a:solidFill>
-                  </a:tcPr>
-                </a:tc>
-              </a:tr>
             </a:tbl>
           </a:graphicData>
         </a:graphic>
@@ -7957,7 +7957,7 @@
                 </a:solidFill>
                 <a:latin typeface="Segoe UI Semibold"/>
               </a:rPr>
-              <a:t>9 Templates  ·  31 Framework Files  ·  2 Workflow Scripts</a:t>
+              <a:t>9 Templates  ·  31 Framework Files  ·  4 Workflow Scripts</a:t>
             </a:r>
           </a:p>
         </p:txBody>
@@ -7972,7 +7972,7 @@
         </p:nvGraphicFramePr>
         <p:xfrm>
           <a:off x="365760" y="4407408"/>
-          <a:ext cx="11460174" cy="2148840"/>
+          <a:ext cx="11460174" cy="2139696"/>
         </p:xfrm>
         <a:graphic>
           <a:graphicData uri="http://schemas.openxmlformats.org/drawingml/2006/table">
@@ -7984,7 +7984,7 @@
                 <a:gridCol w="3896459"/>
                 <a:gridCol w="7563715"/>
               </a:tblGrid>
-              <a:tr h="214884">
+              <a:tr h="178308">
                 <a:tc>
                   <a:txBody>
                     <a:bodyPr/>
@@ -8032,7 +8032,7 @@
                   </a:tcPr>
                 </a:tc>
               </a:tr>
-              <a:tr h="214884">
+              <a:tr h="178308">
                 <a:tc>
                   <a:txBody>
                     <a:bodyPr/>
@@ -8080,7 +8080,7 @@
                   </a:tcPr>
                 </a:tc>
               </a:tr>
-              <a:tr h="214884">
+              <a:tr h="178308">
                 <a:tc>
                   <a:txBody>
                     <a:bodyPr/>
@@ -8128,7 +8128,7 @@
                   </a:tcPr>
                 </a:tc>
               </a:tr>
-              <a:tr h="214884">
+              <a:tr h="178308">
                 <a:tc>
                   <a:txBody>
                     <a:bodyPr/>
@@ -8176,7 +8176,7 @@
                   </a:tcPr>
                 </a:tc>
               </a:tr>
-              <a:tr h="214884">
+              <a:tr h="178308">
                 <a:tc>
                   <a:txBody>
                     <a:bodyPr/>
@@ -8224,7 +8224,7 @@
                   </a:tcPr>
                 </a:tc>
               </a:tr>
-              <a:tr h="214884">
+              <a:tr h="178308">
                 <a:tc>
                   <a:txBody>
                     <a:bodyPr/>
@@ -8272,7 +8272,103 @@
                   </a:tcPr>
                 </a:tc>
               </a:tr>
-              <a:tr h="214884">
+              <a:tr h="178308">
+                <a:tc>
+                  <a:txBody>
+                    <a:bodyPr/>
+                    <a:lstStyle/>
+                    <a:p>
+                      <a:pPr algn="l"/>
+                      <a:r>
+                        <a:rPr sz="900" b="1" i="0">
+                          <a:solidFill>
+                            <a:srgbClr val="1A56DB"/>
+                          </a:solidFill>
+                          <a:latin typeface="Consolas"/>
+                        </a:rPr>
+                        <a:t>workflows/next-batch.js</a:t>
+                      </a:r>
+                    </a:p>
+                  </a:txBody>
+                  <a:tcPr anchor="ctr" marL="73152" marR="73152" marT="18288" marB="18288">
+                    <a:solidFill>
+                      <a:srgbClr val="EBF2FF"/>
+                    </a:solidFill>
+                  </a:tcPr>
+                </a:tc>
+                <a:tc>
+                  <a:txBody>
+                    <a:bodyPr/>
+                    <a:lstStyle/>
+                    <a:p>
+                      <a:pPr algn="l"/>
+                      <a:r>
+                        <a:rPr sz="900" b="0" i="0">
+                          <a:solidFill>
+                            <a:srgbClr val="1F2937"/>
+                          </a:solidFill>
+                          <a:latin typeface="Calibri"/>
+                        </a:rPr>
+                        <a:t>Workflow-tool script — fans out unit-migrator (full mode, no plan gate) across a batch of independent units in parallel, for /next-batch.</a:t>
+                      </a:r>
+                    </a:p>
+                  </a:txBody>
+                  <a:tcPr anchor="ctr" marL="73152" marR="73152" marT="18288" marB="18288">
+                    <a:solidFill>
+                      <a:srgbClr val="EBF2FF"/>
+                    </a:solidFill>
+                  </a:tcPr>
+                </a:tc>
+              </a:tr>
+              <a:tr h="178308">
+                <a:tc>
+                  <a:txBody>
+                    <a:bodyPr/>
+                    <a:lstStyle/>
+                    <a:p>
+                      <a:pPr algn="l"/>
+                      <a:r>
+                        <a:rPr sz="900" b="1" i="0">
+                          <a:solidFill>
+                            <a:srgbClr val="1A56DB"/>
+                          </a:solidFill>
+                          <a:latin typeface="Consolas"/>
+                        </a:rPr>
+                        <a:t>workflows/verify-run.js</a:t>
+                      </a:r>
+                    </a:p>
+                  </a:txBody>
+                  <a:tcPr anchor="ctr" marL="73152" marR="73152" marT="18288" marB="18288">
+                    <a:solidFill>
+                      <a:srgbClr val="FAFBFC"/>
+                    </a:solidFill>
+                  </a:tcPr>
+                </a:tc>
+                <a:tc>
+                  <a:txBody>
+                    <a:bodyPr/>
+                    <a:lstStyle/>
+                    <a:p>
+                      <a:pPr algn="l"/>
+                      <a:r>
+                        <a:rPr sz="900" b="0" i="0">
+                          <a:solidFill>
+                            <a:srgbClr val="1F2937"/>
+                          </a:solidFill>
+                          <a:latin typeface="Calibri"/>
+                        </a:rPr>
+                        <a:t>Workflow-tool script — pipelines per-unit lint/type-check/tests, then fans out parity-reviewer + migration-critic + the dynamic tier, for /verify.</a:t>
+                      </a:r>
+                    </a:p>
+                  </a:txBody>
+                  <a:tcPr anchor="ctr" marL="73152" marR="73152" marT="18288" marB="18288">
+                    <a:solidFill>
+                      <a:srgbClr val="FAFBFC"/>
+                    </a:solidFill>
+                  </a:tcPr>
+                </a:tc>
+              </a:tr>
+              <a:tr h="178308">
                 <a:tc>
                   <a:txBody>
                     <a:bodyPr/>
@@ -8320,7 +8416,7 @@
                   </a:tcPr>
                 </a:tc>
               </a:tr>
-              <a:tr h="214884">
+              <a:tr h="178308">
                 <a:tc>
                   <a:txBody>
                     <a:bodyPr/>
@@ -8368,7 +8464,7 @@
                   </a:tcPr>
                 </a:tc>
               </a:tr>
-              <a:tr h="214884">
+              <a:tr h="178308">
                 <a:tc>
                   <a:txBody>
                     <a:bodyPr/>
@@ -8416,7 +8512,7 @@
                   </a:tcPr>
                 </a:tc>
               </a:tr>
-              <a:tr h="214884">
+              <a:tr h="178308">
                 <a:tc>
                   <a:txBody>
                     <a:bodyPr/>
@@ -9116,7 +9212,7 @@
                 </a:solidFill>
                 <a:latin typeface="Calibri"/>
               </a:rPr>
-              <a:t>web-modernize v0.16.0   ·   github.com/balaji-hari/web-mordernize</a:t>
+              <a:t>web-modernize v0.18.0   ·   github.com/balaji-hari/web-mordernize</a:t>
             </a:r>
           </a:p>
         </p:txBody>
@@ -9415,7 +9511,7 @@
                 </a:solidFill>
                 <a:latin typeface="Calibri"/>
               </a:rPr>
-              <a:t>web-modernize v0.16.0   ·   Balaji Harikrishnan   ·   Cognizant   ·   July 2026</a:t>
+              <a:t>web-modernize v0.18.0   ·   Balaji Harikrishnan   ·   Cognizant   ·   July 2026</a:t>
             </a:r>
           </a:p>
         </p:txBody>
@@ -10246,7 +10342,7 @@
                 </a:solidFill>
                 <a:latin typeface="Calibri"/>
               </a:rPr>
-              <a:t>18 skills exposed as slash commands  ·  6 AI agents (analyzer, migrator, cross-cutting-migrator, parity-reviewer, migration-critic, gotchas catalog)  ·  2 automation hooks  ·  two workflows/ orchestration scripts  ·  9 schema-validated templates copied into the team's repo.</a:t>
+              <a:t>19 skills exposed as slash commands  ·  5 AI agents (analyzer, migrator, cross-cutting-migrator, parity-reviewer, migration-critic)  ·  2 automation hooks  ·  four workflows/ orchestration scripts  ·  9 schema-validated templates copied into the team's repo.</a:t>
             </a:r>
           </a:p>
         </p:txBody>
@@ -10944,7 +11040,7 @@
                 </a:solidFill>
                 <a:latin typeface="Calibri"/>
               </a:rPr>
-              <a:t>web-modernize v0.16.0   ·   Balaji Harikrishnan   ·   Cognizant   ·   July 2026</a:t>
+              <a:t>web-modernize v0.18.0   ·   Balaji Harikrishnan   ·   Cognizant   ·   July 2026</a:t>
             </a:r>
           </a:p>
         </p:txBody>
@@ -11139,7 +11235,7 @@
                 </a:solidFill>
                 <a:latin typeface="Calibri"/>
               </a:rPr>
-              <a:t>Every skill's description now packs intent phrases + a lifecycle anchor. Claude's native skill matcher routes plain-English requests to the right command — developers stop memorising 18 slash commands.</a:t>
+              <a:t>Every skill's description now packs intent phrases + a lifecycle anchor. Claude's native skill matcher routes plain-English requests to the right command — developers stop memorising 19 slash commands.</a:t>
             </a:r>
           </a:p>
         </p:txBody>
@@ -13982,7 +14078,7 @@
                 </a:solidFill>
                 <a:latin typeface="Calibri"/>
               </a:rPr>
-              <a:t>web-modernize v0.16.0   ·   Balaji Harikrishnan   ·   Cognizant   ·   July 2026</a:t>
+              <a:t>web-modernize v0.18.0   ·   Balaji Harikrishnan   ·   Cognizant   ·   July 2026</a:t>
             </a:r>
           </a:p>
         </p:txBody>
@@ -16544,7 +16640,7 @@
                 </a:solidFill>
                 <a:latin typeface="Calibri"/>
               </a:rPr>
-              <a:t>web-modernize v0.16.0   ·   Balaji Harikrishnan   ·   Cognizant   ·   July 2026</a:t>
+              <a:t>web-modernize v0.18.0   ·   Balaji Harikrishnan   ·   Cognizant   ·   July 2026</a:t>
             </a:r>
           </a:p>
         </p:txBody>
@@ -17917,7 +18013,7 @@
                 </a:solidFill>
                 <a:latin typeface="Calibri"/>
               </a:rPr>
-              <a:t>web-modernize v0.16.0   ·   Balaji Harikrishnan   ·   Cognizant   ·   July 2026</a:t>
+              <a:t>web-modernize v0.18.0   ·   Balaji Harikrishnan   ·   Cognizant   ·   July 2026</a:t>
             </a:r>
           </a:p>
         </p:txBody>
@@ -18845,7 +18941,7 @@
                 </a:solidFill>
                 <a:latin typeface="Calibri"/>
               </a:rPr>
-              <a:t>web-modernize v0.16.0   ·   Balaji Harikrishnan   ·   Cognizant   ·   July 2026</a:t>
+              <a:t>web-modernize v0.18.0   ·   Balaji Harikrishnan   ·   Cognizant   ·   July 2026</a:t>
             </a:r>
           </a:p>
         </p:txBody>
@@ -20218,7 +20314,7 @@
                 </a:solidFill>
                 <a:latin typeface="Calibri"/>
               </a:rPr>
-              <a:t>web-modernize v0.16.0   ·   Balaji Harikrishnan   ·   Cognizant   ·   July 2026</a:t>
+              <a:t>web-modernize v0.18.0   ·   Balaji Harikrishnan   ·   Cognizant   ·   July 2026</a:t>
             </a:r>
           </a:p>
         </p:txBody>
@@ -22559,7 +22655,7 @@
                 </a:solidFill>
                 <a:latin typeface="Calibri"/>
               </a:rPr>
-              <a:t>web-modernize v0.16.0   ·   Balaji Harikrishnan   ·   Cognizant   ·   July 2026</a:t>
+              <a:t>web-modernize v0.18.0   ·   Balaji Harikrishnan   ·   Cognizant   ·   July 2026</a:t>
             </a:r>
           </a:p>
         </p:txBody>

</xml_diff>